<commit_message>
Added updated AI ML slides
</commit_message>
<xml_diff>
--- a/downloads/ai_ml_slides.pptx
+++ b/downloads/ai_ml_slides.pptx
@@ -19237,7 +19237,13 @@
           <p:cNvGraphicFramePr>
             <a:graphicFrameLocks noGrp="1"/>
           </p:cNvGraphicFramePr>
-          <p:nvPr/>
+          <p:nvPr>
+            <p:extLst>
+              <p:ext uri="{D42A27DB-BD31-4B8C-83A1-F6EECF244321}">
+                <p14:modId xmlns:p14="http://schemas.microsoft.com/office/powerpoint/2010/main" val="746252091"/>
+              </p:ext>
+            </p:extLst>
+          </p:nvPr>
         </p:nvGraphicFramePr>
         <p:xfrm>
           <a:off x="962024" y="2554099"/>
@@ -19246,7 +19252,7 @@
         <a:graphic>
           <a:graphicData uri="http://schemas.openxmlformats.org/drawingml/2006/table">
             <a:tbl>
-              <a:tblPr/>
+              <a:tblPr firstRow="1"/>
               <a:tblGrid>
                 <a:gridCol w="3171826">
                   <a:extLst>
@@ -19273,7 +19279,7 @@
                         <a:buNone/>
                       </a:pPr>
                       <a:r>
-                        <a:rPr lang="en-US">
+                        <a:rPr lang="en-US" dirty="0">
                           <a:solidFill>
                             <a:schemeClr val="accent1">
                               <a:lumMod val="60000"/>
@@ -19298,7 +19304,12 @@
                     <a:lnB>
                       <a:noFill/>
                     </a:lnB>
-                    <a:noFill/>
+                    <a:solidFill>
+                      <a:schemeClr val="tx2">
+                        <a:lumMod val="90000"/>
+                        <a:lumOff val="10000"/>
+                      </a:schemeClr>
+                    </a:solidFill>
                   </a:tcPr>
                 </a:tc>
                 <a:tc>
@@ -19335,7 +19346,12 @@
                     <a:lnB>
                       <a:noFill/>
                     </a:lnB>
-                    <a:noFill/>
+                    <a:solidFill>
+                      <a:schemeClr val="tx2">
+                        <a:lumMod val="90000"/>
+                        <a:lumOff val="10000"/>
+                      </a:schemeClr>
+                    </a:solidFill>
                   </a:tcPr>
                 </a:tc>
                 <a:extLst>
@@ -19538,7 +19554,7 @@
                         <a:buNone/>
                       </a:pPr>
                       <a:r>
-                        <a:rPr lang="en-US">
+                        <a:rPr lang="en-US" dirty="0">
                           <a:solidFill>
                             <a:schemeClr val="bg1"/>
                           </a:solidFill>

</xml_diff>

<commit_message>
Added ollama slides, more alt text, grammar fixes to slides
</commit_message>
<xml_diff>
--- a/downloads/ai_ml_slides.pptx
+++ b/downloads/ai_ml_slides.pptx
@@ -5,7 +5,7 @@
     <p:sldMasterId id="2147483648" r:id="rId1"/>
   </p:sldMasterIdLst>
   <p:notesMasterIdLst>
-    <p:notesMasterId r:id="rId59"/>
+    <p:notesMasterId r:id="rId62"/>
   </p:notesMasterIdLst>
   <p:sldIdLst>
     <p:sldId id="292" r:id="rId2"/>
@@ -64,12 +64,15 @@
     <p:sldId id="321" r:id="rId55"/>
     <p:sldId id="322" r:id="rId56"/>
     <p:sldId id="351" r:id="rId57"/>
-    <p:sldId id="333" r:id="rId58"/>
+    <p:sldId id="352" r:id="rId58"/>
+    <p:sldId id="353" r:id="rId59"/>
+    <p:sldId id="355" r:id="rId60"/>
+    <p:sldId id="333" r:id="rId61"/>
   </p:sldIdLst>
   <p:sldSz cx="12192000" cy="6858000"/>
   <p:notesSz cx="6858000" cy="9144000"/>
   <p:custDataLst>
-    <p:tags r:id="rId60"/>
+    <p:tags r:id="rId63"/>
   </p:custDataLst>
   <p:defaultTextStyle>
     <a:defPPr>
@@ -211,6 +214,10 @@
             <p14:sldId id="311"/>
             <p14:sldId id="310"/>
             <p14:sldId id="312"/>
+          </p14:sldIdLst>
+        </p14:section>
+        <p14:section name="6. Nerd Slides - Transformer Specifics" id="{E4916234-9103-4957-A512-34FDA6AA6179}">
+          <p14:sldIdLst>
             <p14:sldId id="336"/>
             <p14:sldId id="337"/>
             <p14:sldId id="335"/>
@@ -221,13 +228,17 @@
             <p14:sldId id="347"/>
             <p14:sldId id="348"/>
             <p14:sldId id="349"/>
+          </p14:sldIdLst>
+        </p14:section>
+        <p14:section name="7. LLMs and GPTs, continued" id="{7FF7145B-F3C6-4AFD-86D1-6870ABF6116E}">
+          <p14:sldIdLst>
             <p14:sldId id="314"/>
             <p14:sldId id="315"/>
             <p14:sldId id="317"/>
             <p14:sldId id="318"/>
           </p14:sldIdLst>
         </p14:section>
-        <p14:section name="6. Ryan's (Generative) AI Resources" id="{DE393048-F57A-D64B-BC21-8807481A5C5A}">
+        <p14:section name="8. Ryan's Generative AI Resources" id="{DE393048-F57A-D64B-BC21-8807481A5C5A}">
           <p14:sldIdLst>
             <p14:sldId id="326"/>
             <p14:sldId id="328"/>
@@ -237,7 +248,7 @@
             <p14:sldId id="329"/>
           </p14:sldIdLst>
         </p14:section>
-        <p14:section name="7. Other Ethical Concerns (Not Comprehensive)" id="{3706D3CC-5A88-DF42-AE6E-796634A3759B}">
+        <p14:section name="9. Other Ethical Concerns (Not Comprehensive)" id="{3706D3CC-5A88-DF42-AE6E-796634A3759B}">
           <p14:sldIdLst>
             <p14:sldId id="327"/>
             <p14:sldId id="260"/>
@@ -255,6 +266,13 @@
             <p14:sldId id="321"/>
             <p14:sldId id="322"/>
             <p14:sldId id="351"/>
+          </p14:sldIdLst>
+        </p14:section>
+        <p14:section name="10. LLM Privacy with Ollama" id="{8ED564F1-62CD-4C3E-A30E-E03DB69AB45A}">
+          <p14:sldIdLst>
+            <p14:sldId id="352"/>
+            <p14:sldId id="353"/>
+            <p14:sldId id="355"/>
             <p14:sldId id="333"/>
           </p14:sldIdLst>
         </p14:section>
@@ -349,7 +367,7 @@
           <a:p>
             <a:fld id="{FC353D21-AFFF-4353-815A-DF65D9157940}" type="datetimeFigureOut">
               <a:rPr lang="en-US" smtClean="0"/>
-              <a:t>4/13/2026</a:t>
+              <a:t>4/15/2026</a:t>
             </a:fld>
             <a:endParaRPr lang="en-US"/>
           </a:p>
@@ -1406,7 +1424,7 @@
             <a:fld id="{BF3F64B4-C509-489E-B9E0-3C1C30B4AF8A}" type="datetimeFigureOut">
               <a:rPr lang="en-US" smtClean="0"/>
               <a:pPr/>
-              <a:t>4/13/2026</a:t>
+              <a:t>4/15/2026</a:t>
             </a:fld>
             <a:endParaRPr lang="en-US" dirty="0"/>
           </a:p>
@@ -1649,7 +1667,7 @@
             <a:fld id="{BF3F64B4-C509-489E-B9E0-3C1C30B4AF8A}" type="datetimeFigureOut">
               <a:rPr lang="en-US" smtClean="0"/>
               <a:pPr/>
-              <a:t>4/13/2026</a:t>
+              <a:t>4/15/2026</a:t>
             </a:fld>
             <a:endParaRPr lang="en-US"/>
           </a:p>
@@ -2201,7 +2219,7 @@
             <a:fld id="{BF3F64B4-C509-489E-B9E0-3C1C30B4AF8A}" type="datetimeFigureOut">
               <a:rPr lang="en-US" smtClean="0"/>
               <a:pPr/>
-              <a:t>4/13/2026</a:t>
+              <a:t>4/15/2026</a:t>
             </a:fld>
             <a:endParaRPr lang="en-US"/>
           </a:p>
@@ -2496,7 +2514,7 @@
             <a:fld id="{BF3F64B4-C509-489E-B9E0-3C1C30B4AF8A}" type="datetimeFigureOut">
               <a:rPr lang="en-US" smtClean="0"/>
               <a:pPr/>
-              <a:t>4/13/2026</a:t>
+              <a:t>4/15/2026</a:t>
             </a:fld>
             <a:endParaRPr lang="en-US"/>
           </a:p>
@@ -3908,7 +3926,7 @@
           <a:p>
             <a:fld id="{BF3F64B4-C509-489E-B9E0-3C1C30B4AF8A}" type="datetimeFigureOut">
               <a:rPr lang="en-US" smtClean="0"/>
-              <a:t>4/13/2026</a:t>
+              <a:t>4/15/2026</a:t>
             </a:fld>
             <a:endParaRPr lang="en-US"/>
           </a:p>
@@ -4421,7 +4439,7 @@
             <a:fld id="{BF3F64B4-C509-489E-B9E0-3C1C30B4AF8A}" type="datetimeFigureOut">
               <a:rPr lang="en-US" smtClean="0"/>
               <a:pPr/>
-              <a:t>4/13/2026</a:t>
+              <a:t>4/15/2026</a:t>
             </a:fld>
             <a:endParaRPr lang="en-US" dirty="0"/>
           </a:p>
@@ -4872,7 +4890,7 @@
             <a:fld id="{BF3F64B4-C509-489E-B9E0-3C1C30B4AF8A}" type="datetimeFigureOut">
               <a:rPr lang="en-US" smtClean="0"/>
               <a:pPr/>
-              <a:t>4/13/2026</a:t>
+              <a:t>4/15/2026</a:t>
             </a:fld>
             <a:endParaRPr lang="en-US"/>
           </a:p>
@@ -5189,7 +5207,7 @@
             <a:fld id="{BF3F64B4-C509-489E-B9E0-3C1C30B4AF8A}" type="datetimeFigureOut">
               <a:rPr lang="en-US" smtClean="0"/>
               <a:pPr/>
-              <a:t>4/13/2026</a:t>
+              <a:t>4/15/2026</a:t>
             </a:fld>
             <a:endParaRPr lang="en-US"/>
           </a:p>
@@ -5506,7 +5524,7 @@
             <a:fld id="{BF3F64B4-C509-489E-B9E0-3C1C30B4AF8A}" type="datetimeFigureOut">
               <a:rPr lang="en-US" smtClean="0"/>
               <a:pPr/>
-              <a:t>4/13/2026</a:t>
+              <a:t>4/15/2026</a:t>
             </a:fld>
             <a:endParaRPr lang="en-US" dirty="0"/>
           </a:p>
@@ -5823,7 +5841,7 @@
             <a:fld id="{BF3F64B4-C509-489E-B9E0-3C1C30B4AF8A}" type="datetimeFigureOut">
               <a:rPr lang="en-US" smtClean="0"/>
               <a:pPr/>
-              <a:t>4/13/2026</a:t>
+              <a:t>4/15/2026</a:t>
             </a:fld>
             <a:endParaRPr lang="en-US"/>
           </a:p>
@@ -6139,7 +6157,7 @@
             <a:fld id="{BF3F64B4-C509-489E-B9E0-3C1C30B4AF8A}" type="datetimeFigureOut">
               <a:rPr lang="en-US" smtClean="0"/>
               <a:pPr/>
-              <a:t>4/13/2026</a:t>
+              <a:t>4/15/2026</a:t>
             </a:fld>
             <a:endParaRPr lang="en-US"/>
           </a:p>
@@ -6573,7 +6591,7 @@
             <a:fld id="{BF3F64B4-C509-489E-B9E0-3C1C30B4AF8A}" type="datetimeFigureOut">
               <a:rPr lang="en-US" smtClean="0"/>
               <a:pPr/>
-              <a:t>4/13/2026</a:t>
+              <a:t>4/15/2026</a:t>
             </a:fld>
             <a:endParaRPr lang="en-US"/>
           </a:p>
@@ -7125,7 +7143,7 @@
             <a:fld id="{BF3F64B4-C509-489E-B9E0-3C1C30B4AF8A}" type="datetimeFigureOut">
               <a:rPr lang="en-US" smtClean="0"/>
               <a:pPr/>
-              <a:t>4/13/2026</a:t>
+              <a:t>4/15/2026</a:t>
             </a:fld>
             <a:endParaRPr lang="en-US"/>
           </a:p>
@@ -7749,7 +7767,7 @@
           <a:p>
             <a:fld id="{BF3F64B4-C509-489E-B9E0-3C1C30B4AF8A}" type="datetimeFigureOut">
               <a:rPr lang="en-US" smtClean="0"/>
-              <a:t>4/13/2026</a:t>
+              <a:t>4/15/2026</a:t>
             </a:fld>
             <a:endParaRPr lang="en-US"/>
           </a:p>
@@ -9102,7 +9120,7 @@
       </p:sp>
       <p:pic>
         <p:nvPicPr>
-          <p:cNvPr id="12" name="Picture 11">
+          <p:cNvPr id="12" name="Picture 11" descr="Diagram of basic neural network with two inputs--weight and height--a middle/hidden layer of two neurons that receive height and weight values, connected to a final output neuron that outputs a prediction of gender based on height and weight">
             <a:extLst>
               <a:ext uri="{FF2B5EF4-FFF2-40B4-BE49-F238E27FC236}">
                 <a16:creationId xmlns:a16="http://schemas.microsoft.com/office/drawing/2014/main" id="{F31488E0-0917-440A-755A-C85EA1BFF7C4}"/>
@@ -13771,7 +13789,7 @@
       </p:sp>
       <p:pic>
         <p:nvPicPr>
-          <p:cNvPr id="11" name="Picture 10">
+          <p:cNvPr id="11" name="Picture 10" descr="Diagram showing single perceptron - two neurons as input and one neuron as output as building block in a hidden layer network with input, hidden layer and output, and hidden layer network as subset of a deep neural network -- that is -- a network of networks like a brain -- that can train on massive data to create a generative AI model that sees images, understand audio and generate images, audio, text, and code.">
             <a:extLst>
               <a:ext uri="{FF2B5EF4-FFF2-40B4-BE49-F238E27FC236}">
                 <a16:creationId xmlns:a16="http://schemas.microsoft.com/office/drawing/2014/main" id="{C5F6748B-84C0-2E44-3EF8-65BE24B7CB2B}"/>
@@ -16075,7 +16093,7 @@
       </p:grpSpPr>
       <p:pic>
         <p:nvPicPr>
-          <p:cNvPr id="5" name="Graphic 4">
+          <p:cNvPr id="5" name="Graphic 4" descr="2-D graph with age on y-axis and royalty on x. Toward top left words man and woman plotted closely together indicating low royalty, high age. Toward top right queen and king indicating high royalty, high age. Prince and princess are less but still high royalty but lower age putting them on bottom right of graph parallel to boy and girl which are clustered near each other on bottom left. Baby sits near zero of both axes">
             <a:extLst>
               <a:ext uri="{FF2B5EF4-FFF2-40B4-BE49-F238E27FC236}">
                 <a16:creationId xmlns:a16="http://schemas.microsoft.com/office/drawing/2014/main" id="{7BEE7D5D-7CE2-A3AC-94B0-F483A17C4A4D}"/>
@@ -16459,7 +16477,7 @@
       </p:grpSpPr>
       <p:pic>
         <p:nvPicPr>
-          <p:cNvPr id="5" name="Graphic 4">
+          <p:cNvPr id="5" name="Graphic 4" descr="2-D graph from previous slide&#10;">
             <a:extLst>
               <a:ext uri="{FF2B5EF4-FFF2-40B4-BE49-F238E27FC236}">
                 <a16:creationId xmlns:a16="http://schemas.microsoft.com/office/drawing/2014/main" id="{B91C86F7-BAD2-D250-CF27-C3AF2609704C}"/>
@@ -16897,7 +16915,7 @@
       </p:sp>
       <p:pic>
         <p:nvPicPr>
-          <p:cNvPr id="8" name="Picture 7">
+          <p:cNvPr id="8" name="Picture 7" descr="Previous 2-D diagram enhanced with third dimension: gender. words like woman and man, queen, and king are on opposite ends of gender axis. Baby has neutral connotation in middle of its axis">
             <a:extLst>
               <a:ext uri="{FF2B5EF4-FFF2-40B4-BE49-F238E27FC236}">
                 <a16:creationId xmlns:a16="http://schemas.microsoft.com/office/drawing/2014/main" id="{7D54DFB8-ADE4-9C77-7645-3AA2724FE927}"/>
@@ -17875,7 +17893,7 @@
             </a:r>
             <a:r>
               <a:rPr lang="en-US" dirty="0"/>
-              <a:t>: The heart of the transformer: Each token computes 3 vectors – Query, Key, &amp; Value (explained next) – to determine how much attention it should pay to every other word in the sequence. → Let’s model predict the meaning of “bank” next to “river” vs. “bank” next to “deposit”.</a:t>
+              <a:t>: The heart of the transformer: Each token computes 3 vectors – Query, Key, &amp; Value (explained next) – to determine how much attention it should pay to every other word in the sequence. → Lets model predict the meaning of “bank” next to “river” vs. “bank” next to “deposit”.</a:t>
             </a:r>
           </a:p>
         </p:txBody>
@@ -18187,7 +18205,7 @@
             </a:r>
             <a:r>
               <a:rPr lang="en-US" dirty="0"/>
-              <a:t>: “What do I offer”</a:t>
+              <a:t>: “What do I offer?”</a:t>
             </a:r>
           </a:p>
           <a:p>
@@ -19031,13 +19049,13 @@
         </p:spPr>
         <p:txBody>
           <a:bodyPr>
-            <a:normAutofit fontScale="90000"/>
+            <a:noAutofit/>
           </a:bodyPr>
           <a:lstStyle/>
           <a:p>
             <a:r>
-              <a:rPr lang="en-US" dirty="0"/>
-              <a:t>Multi-Head Attention / Contextual Understanding</a:t>
+              <a:rPr lang="en-US" sz="3000" dirty="0"/>
+              <a:t>MULTI-HEAD ATT’N = CONTEXTUAL UNDERSTANDING</a:t>
             </a:r>
           </a:p>
         </p:txBody>
@@ -19445,7 +19463,7 @@
                         <a:buNone/>
                       </a:pPr>
                       <a:r>
-                        <a:rPr lang="en-US">
+                        <a:rPr lang="en-US" dirty="0">
                           <a:solidFill>
                             <a:schemeClr val="bg1"/>
                           </a:solidFill>
@@ -19595,7 +19613,7 @@
                         <a:buNone/>
                       </a:pPr>
                       <a:r>
-                        <a:rPr lang="en-US">
+                        <a:rPr lang="en-US" dirty="0">
                           <a:solidFill>
                             <a:schemeClr val="bg1"/>
                           </a:solidFill>
@@ -23982,7 +24000,8 @@
       </p:pic>
       <p:pic>
         <p:nvPicPr>
-          <p:cNvPr id="3078" name="Picture 6" descr="CDN media">
+          <p:cNvPr id="3078" name="Picture 6" descr="Cartoon meme of person with two paths at trailhead. Both lead to foreboding haunted mansion with thunderclouds and lightning.">
+            <a:hlinkClick r:id="rId4" action="ppaction://hlinkfile"/>
             <a:extLst>
               <a:ext uri="{FF2B5EF4-FFF2-40B4-BE49-F238E27FC236}">
                 <a16:creationId xmlns:a16="http://schemas.microsoft.com/office/drawing/2014/main" id="{BDC515A0-30EA-9A4C-5DB6-BBA7E71428E3}"/>
@@ -23995,7 +24014,7 @@
           <p:nvPr/>
         </p:nvPicPr>
         <p:blipFill>
-          <a:blip r:embed="rId4">
+          <a:blip r:embed="rId5">
             <a:extLst>
               <a:ext uri="{28A0092B-C50C-407E-A947-70E740481C1C}">
                 <a14:useLocalDpi xmlns:a14="http://schemas.microsoft.com/office/drawing/2010/main" val="0"/>
@@ -27376,7 +27395,7 @@
       </p:sp>
       <p:pic>
         <p:nvPicPr>
-          <p:cNvPr id="4" name="Picture 2" descr="CDN media">
+          <p:cNvPr id="4" name="Picture 2" descr="Wii Sports message with Wii remote set down and open window: 'Why not take a break? You can pause the game by pressing plus'">
             <a:extLst>
               <a:ext uri="{FF2B5EF4-FFF2-40B4-BE49-F238E27FC236}">
                 <a16:creationId xmlns:a16="http://schemas.microsoft.com/office/drawing/2014/main" id="{41E80C76-84E1-F9B1-30BB-7AE570914424}"/>
@@ -27903,7 +27922,7 @@
             </a:r>
             <a:r>
               <a:rPr lang="en-US" dirty="0"/>
-              <a:t>: Through outsourcing partner, Sama, Open AI outsourced labelers in Kenya, Uganda, &amp; India had labelers classifying &amp; filtering horrific text and images for $1.32-2 [1,3]</a:t>
+              <a:t>: Through outsourcing partner, Sama, Open AI outsourced labelers in Kenya, Uganda, &amp; India; had labelers classifying &amp; filtering horrific text and images for $1.32-2 [1,3]</a:t>
             </a:r>
           </a:p>
           <a:p>
@@ -29182,7 +29201,7 @@
               <a:rPr lang="en-US" dirty="0">
                 <a:sym typeface="Wingdings" panose="05000000000000000000" pitchFamily="2" charset="2"/>
               </a:rPr>
-              <a:t>: Tracking content consumption over time predicts susceptibility to specific political messaging  when paired with the write psychometrics, valuable for curating messaging for demographics </a:t>
+              <a:t>: Tracking content consumption over time predicts susceptibility to specific political messaging  when paired with the right psychometrics, valuable for curating messaging for demographics </a:t>
             </a:r>
             <a:r>
               <a:rPr lang="en-US" sz="2500" dirty="0">
@@ -31247,6 +31266,430 @@
   <p:cSld>
     <p:spTree>
       <p:nvGrpSpPr>
+        <p:cNvPr id="1" name="">
+          <a:extLst>
+            <a:ext uri="{FF2B5EF4-FFF2-40B4-BE49-F238E27FC236}">
+              <a16:creationId xmlns:a16="http://schemas.microsoft.com/office/drawing/2014/main" id="{4CDBD27D-17D3-90F4-EC3C-B2C946702A6B}"/>
+            </a:ext>
+          </a:extLst>
+        </p:cNvPr>
+        <p:cNvGrpSpPr/>
+        <p:nvPr/>
+      </p:nvGrpSpPr>
+      <p:grpSpPr>
+        <a:xfrm>
+          <a:off x="0" y="0"/>
+          <a:ext cx="0" cy="0"/>
+          <a:chOff x="0" y="0"/>
+          <a:chExt cx="0" cy="0"/>
+        </a:xfrm>
+      </p:grpSpPr>
+      <p:sp>
+        <p:nvSpPr>
+          <p:cNvPr id="2" name="Title 1">
+            <a:extLst>
+              <a:ext uri="{FF2B5EF4-FFF2-40B4-BE49-F238E27FC236}">
+                <a16:creationId xmlns:a16="http://schemas.microsoft.com/office/drawing/2014/main" id="{37C51485-93FC-16F3-A4F5-9E2158483D6C}"/>
+              </a:ext>
+            </a:extLst>
+          </p:cNvPr>
+          <p:cNvSpPr>
+            <a:spLocks noGrp="1"/>
+          </p:cNvSpPr>
+          <p:nvPr>
+            <p:ph type="title"/>
+          </p:nvPr>
+        </p:nvSpPr>
+        <p:spPr/>
+        <p:txBody>
+          <a:bodyPr/>
+          <a:lstStyle/>
+          <a:p>
+            <a:r>
+              <a:rPr lang="en-US" dirty="0"/>
+              <a:t>LLM PRIVACY: LOCAL AI WITH OLLAMA</a:t>
+            </a:r>
+            <a:endParaRPr lang="en-US" sz="2000" dirty="0"/>
+          </a:p>
+        </p:txBody>
+      </p:sp>
+      <p:sp>
+        <p:nvSpPr>
+          <p:cNvPr id="3" name="Content Placeholder 2">
+            <a:extLst>
+              <a:ext uri="{FF2B5EF4-FFF2-40B4-BE49-F238E27FC236}">
+                <a16:creationId xmlns:a16="http://schemas.microsoft.com/office/drawing/2014/main" id="{D0BEDCB4-08FE-15F8-10E7-6885561A499B}"/>
+              </a:ext>
+            </a:extLst>
+          </p:cNvPr>
+          <p:cNvSpPr>
+            <a:spLocks noGrp="1"/>
+          </p:cNvSpPr>
+          <p:nvPr>
+            <p:ph idx="1"/>
+          </p:nvPr>
+        </p:nvSpPr>
+        <p:spPr>
+          <a:xfrm>
+            <a:off x="838200" y="1390650"/>
+            <a:ext cx="5521657" cy="4965700"/>
+          </a:xfrm>
+        </p:spPr>
+        <p:txBody>
+          <a:bodyPr>
+            <a:normAutofit lnSpcReduction="10000"/>
+          </a:bodyPr>
+          <a:lstStyle/>
+          <a:p>
+            <a:pPr marL="0" indent="0">
+              <a:buNone/>
+            </a:pPr>
+            <a:r>
+              <a:rPr lang="en-US" dirty="0">
+                <a:sym typeface="Wingdings" panose="05000000000000000000" pitchFamily="2" charset="2"/>
+              </a:rPr>
+              <a:t>You can use some LLMs locally offline, without an account.</a:t>
+            </a:r>
+          </a:p>
+          <a:p>
+            <a:r>
+              <a:rPr lang="en-US" dirty="0">
+                <a:sym typeface="Wingdings" panose="05000000000000000000" pitchFamily="2" charset="2"/>
+              </a:rPr>
+              <a:t>Frontier large language models require the immense computational power of distributed networks of high-end graphics cards in dedicated data centers.</a:t>
+            </a:r>
+          </a:p>
+          <a:p>
+            <a:r>
+              <a:rPr lang="en-US" dirty="0">
+                <a:sym typeface="Wingdings" panose="05000000000000000000" pitchFamily="2" charset="2"/>
+              </a:rPr>
+              <a:t>You can, however, run small LLMs on your own hardware. </a:t>
+            </a:r>
+            <a:r>
+              <a:rPr lang="en-US" dirty="0" err="1">
+                <a:sym typeface="Wingdings" panose="05000000000000000000" pitchFamily="2" charset="2"/>
+                <a:hlinkClick r:id="rId2"/>
+              </a:rPr>
+              <a:t>Ollama</a:t>
+            </a:r>
+            <a:r>
+              <a:rPr lang="en-US" dirty="0">
+                <a:sym typeface="Wingdings" panose="05000000000000000000" pitchFamily="2" charset="2"/>
+              </a:rPr>
+              <a:t> is one of the most popular, user-friendly tools for this.</a:t>
+            </a:r>
+          </a:p>
+          <a:p>
+            <a:endParaRPr lang="en-US" dirty="0">
+              <a:sym typeface="Wingdings" panose="05000000000000000000" pitchFamily="2" charset="2"/>
+            </a:endParaRPr>
+          </a:p>
+        </p:txBody>
+      </p:sp>
+      <p:sp>
+        <p:nvSpPr>
+          <p:cNvPr id="4" name="TextBox 3">
+            <a:extLst>
+              <a:ext uri="{FF2B5EF4-FFF2-40B4-BE49-F238E27FC236}">
+                <a16:creationId xmlns:a16="http://schemas.microsoft.com/office/drawing/2014/main" id="{8E46B237-D239-4DD2-2F81-DBEE8279BEF7}"/>
+              </a:ext>
+            </a:extLst>
+          </p:cNvPr>
+          <p:cNvSpPr txBox="1"/>
+          <p:nvPr/>
+        </p:nvSpPr>
+        <p:spPr>
+          <a:xfrm>
+            <a:off x="6567363" y="5807449"/>
+            <a:ext cx="5039647" cy="830997"/>
+          </a:xfrm>
+          <a:prstGeom prst="rect">
+            <a:avLst/>
+          </a:prstGeom>
+          <a:noFill/>
+        </p:spPr>
+        <p:txBody>
+          <a:bodyPr wrap="square" rtlCol="0">
+            <a:spAutoFit/>
+          </a:bodyPr>
+          <a:lstStyle/>
+          <a:p>
+            <a:r>
+              <a:rPr lang="en-US" sz="1600" dirty="0">
+                <a:solidFill>
+                  <a:schemeClr val="bg1"/>
+                </a:solidFill>
+              </a:rPr>
+              <a:t>Above: </a:t>
+            </a:r>
+            <a:r>
+              <a:rPr lang="en-US" sz="1600" dirty="0" err="1">
+                <a:solidFill>
+                  <a:schemeClr val="bg1"/>
+                </a:solidFill>
+              </a:rPr>
+              <a:t>Ollama</a:t>
+            </a:r>
+            <a:r>
+              <a:rPr lang="en-US" sz="1600" dirty="0">
+                <a:solidFill>
+                  <a:schemeClr val="bg1"/>
+                </a:solidFill>
+              </a:rPr>
+              <a:t> installs with an out-of-the-box bare-bones chat interface that now supports file/image upload &amp; ‘Thinking level’ for supported models.</a:t>
+            </a:r>
+          </a:p>
+        </p:txBody>
+      </p:sp>
+      <p:pic>
+        <p:nvPicPr>
+          <p:cNvPr id="6" name="Picture 5" descr="Ollama chat interface">
+            <a:extLst>
+              <a:ext uri="{FF2B5EF4-FFF2-40B4-BE49-F238E27FC236}">
+                <a16:creationId xmlns:a16="http://schemas.microsoft.com/office/drawing/2014/main" id="{6FF65836-5FB6-F56F-F779-AC3896C51252}"/>
+              </a:ext>
+            </a:extLst>
+          </p:cNvPr>
+          <p:cNvPicPr>
+            <a:picLocks noChangeAspect="1"/>
+          </p:cNvPicPr>
+          <p:nvPr/>
+        </p:nvPicPr>
+        <p:blipFill>
+          <a:blip r:embed="rId3"/>
+          <a:stretch>
+            <a:fillRect/>
+          </a:stretch>
+        </p:blipFill>
+        <p:spPr>
+          <a:xfrm>
+            <a:off x="6566647" y="1050551"/>
+            <a:ext cx="5040364" cy="4721683"/>
+          </a:xfrm>
+          <a:prstGeom prst="rect">
+            <a:avLst/>
+          </a:prstGeom>
+        </p:spPr>
+      </p:pic>
+    </p:spTree>
+    <p:extLst>
+      <p:ext uri="{BB962C8B-B14F-4D97-AF65-F5344CB8AC3E}">
+        <p14:creationId xmlns:p14="http://schemas.microsoft.com/office/powerpoint/2010/main" val="1043578819"/>
+      </p:ext>
+    </p:extLst>
+  </p:cSld>
+  <p:clrMapOvr>
+    <a:masterClrMapping/>
+  </p:clrMapOvr>
+</p:sld>
+</file>
+
+<file path=ppt/slides/slide58.xml><?xml version="1.0" encoding="utf-8"?>
+<p:sld xmlns:a="http://schemas.openxmlformats.org/drawingml/2006/main" xmlns:r="http://schemas.openxmlformats.org/officeDocument/2006/relationships" xmlns:p="http://schemas.openxmlformats.org/presentationml/2006/main">
+  <p:cSld>
+    <p:spTree>
+      <p:nvGrpSpPr>
+        <p:cNvPr id="1" name="">
+          <a:extLst>
+            <a:ext uri="{FF2B5EF4-FFF2-40B4-BE49-F238E27FC236}">
+              <a16:creationId xmlns:a16="http://schemas.microsoft.com/office/drawing/2014/main" id="{5A9679B6-A436-51DE-EE92-FC3A8CF31B0A}"/>
+            </a:ext>
+          </a:extLst>
+        </p:cNvPr>
+        <p:cNvGrpSpPr/>
+        <p:nvPr/>
+      </p:nvGrpSpPr>
+      <p:grpSpPr>
+        <a:xfrm>
+          <a:off x="0" y="0"/>
+          <a:ext cx="0" cy="0"/>
+          <a:chOff x="0" y="0"/>
+          <a:chExt cx="0" cy="0"/>
+        </a:xfrm>
+      </p:grpSpPr>
+      <p:sp>
+        <p:nvSpPr>
+          <p:cNvPr id="2" name="Title 1">
+            <a:extLst>
+              <a:ext uri="{FF2B5EF4-FFF2-40B4-BE49-F238E27FC236}">
+                <a16:creationId xmlns:a16="http://schemas.microsoft.com/office/drawing/2014/main" id="{71EBE5A4-FC6D-2B9D-1F3B-AAB1A67BC855}"/>
+              </a:ext>
+            </a:extLst>
+          </p:cNvPr>
+          <p:cNvSpPr>
+            <a:spLocks noGrp="1"/>
+          </p:cNvSpPr>
+          <p:nvPr>
+            <p:ph type="title"/>
+          </p:nvPr>
+        </p:nvSpPr>
+        <p:spPr/>
+        <p:txBody>
+          <a:bodyPr/>
+          <a:lstStyle/>
+          <a:p>
+            <a:r>
+              <a:rPr lang="en-US" dirty="0"/>
+              <a:t>OLLAMA – SELECTING MODELS</a:t>
+            </a:r>
+            <a:endParaRPr lang="en-US" sz="2000" dirty="0"/>
+          </a:p>
+        </p:txBody>
+      </p:sp>
+      <p:sp>
+        <p:nvSpPr>
+          <p:cNvPr id="3" name="Content Placeholder 2">
+            <a:extLst>
+              <a:ext uri="{FF2B5EF4-FFF2-40B4-BE49-F238E27FC236}">
+                <a16:creationId xmlns:a16="http://schemas.microsoft.com/office/drawing/2014/main" id="{83EF18D1-8A9F-1AD2-0AF4-9C5C55C745F3}"/>
+              </a:ext>
+            </a:extLst>
+          </p:cNvPr>
+          <p:cNvSpPr>
+            <a:spLocks noGrp="1"/>
+          </p:cNvSpPr>
+          <p:nvPr>
+            <p:ph idx="1"/>
+          </p:nvPr>
+        </p:nvSpPr>
+        <p:spPr>
+          <a:xfrm>
+            <a:off x="838200" y="1390650"/>
+            <a:ext cx="7869072" cy="4965700"/>
+          </a:xfrm>
+        </p:spPr>
+        <p:txBody>
+          <a:bodyPr>
+            <a:normAutofit fontScale="92500" lnSpcReduction="10000"/>
+          </a:bodyPr>
+          <a:lstStyle/>
+          <a:p>
+            <a:pPr marL="0" indent="0">
+              <a:buNone/>
+            </a:pPr>
+            <a:r>
+              <a:rPr lang="en-US" dirty="0">
+                <a:sym typeface="Wingdings" panose="05000000000000000000" pitchFamily="2" charset="2"/>
+              </a:rPr>
+              <a:t>Browsing for models: </a:t>
+            </a:r>
+            <a:r>
+              <a:rPr lang="en-US" dirty="0">
+                <a:solidFill>
+                  <a:schemeClr val="accent4"/>
+                </a:solidFill>
+                <a:sym typeface="Wingdings" panose="05000000000000000000" pitchFamily="2" charset="2"/>
+              </a:rPr>
+              <a:t>ollama.com/search</a:t>
+            </a:r>
+          </a:p>
+          <a:p>
+            <a:r>
+              <a:rPr lang="en-US" dirty="0">
+                <a:sym typeface="Wingdings" panose="05000000000000000000" pitchFamily="2" charset="2"/>
+              </a:rPr>
+              <a:t>Model sizes are represented in billions of parameters, e.g., </a:t>
+            </a:r>
+            <a:r>
+              <a:rPr lang="en-US" dirty="0">
+                <a:solidFill>
+                  <a:schemeClr val="accent4"/>
+                </a:solidFill>
+                <a:sym typeface="Wingdings" panose="05000000000000000000" pitchFamily="2" charset="2"/>
+              </a:rPr>
+              <a:t>gemma4:26b</a:t>
+            </a:r>
+            <a:r>
+              <a:rPr lang="en-US" dirty="0">
+                <a:sym typeface="Wingdings" panose="05000000000000000000" pitchFamily="2" charset="2"/>
+              </a:rPr>
+              <a:t> means </a:t>
+            </a:r>
+            <a:r>
+              <a:rPr lang="en-US" i="1" dirty="0">
+                <a:sym typeface="Wingdings" panose="05000000000000000000" pitchFamily="2" charset="2"/>
+              </a:rPr>
+              <a:t>“the 24-billion-parameter version of the gemma4 model”.</a:t>
+            </a:r>
+          </a:p>
+          <a:p>
+            <a:pPr lvl="1"/>
+            <a:r>
+              <a:rPr lang="en-US" dirty="0">
+                <a:sym typeface="Wingdings" panose="05000000000000000000" pitchFamily="2" charset="2"/>
+              </a:rPr>
+              <a:t>In my experience, you tend to need a high-end GPU, such as an NVIDIA RTX 4070 or 4090, and a generous amount of RAM (32 GB) for models around the 20b size.</a:t>
+            </a:r>
+          </a:p>
+          <a:p>
+            <a:pPr lvl="1"/>
+            <a:r>
+              <a:rPr lang="en-US" dirty="0">
+                <a:sym typeface="Wingdings" panose="05000000000000000000" pitchFamily="2" charset="2"/>
+              </a:rPr>
+              <a:t>Laptops with ~16+ GB RAM + NVIDIA graphics or Apple Silicon (e.g., M3-M5 series MacBooks) may be able to run models up to ~12b parameters before getting too slow.</a:t>
+            </a:r>
+          </a:p>
+          <a:p>
+            <a:r>
+              <a:rPr lang="en-US" dirty="0">
+                <a:sym typeface="Wingdings" panose="05000000000000000000" pitchFamily="2" charset="2"/>
+              </a:rPr>
+              <a:t>More constrained hardware might only be able to run 1-to-2b-parameter models, limiting the utility of the model.</a:t>
+            </a:r>
+          </a:p>
+        </p:txBody>
+      </p:sp>
+      <p:pic>
+        <p:nvPicPr>
+          <p:cNvPr id="9" name="Picture 8" descr="List of Gemma 4 language model variants">
+            <a:extLst>
+              <a:ext uri="{FF2B5EF4-FFF2-40B4-BE49-F238E27FC236}">
+                <a16:creationId xmlns:a16="http://schemas.microsoft.com/office/drawing/2014/main" id="{5B76EC16-3AA6-E4FA-592F-D08B5DEBDD5C}"/>
+              </a:ext>
+            </a:extLst>
+          </p:cNvPr>
+          <p:cNvPicPr>
+            <a:picLocks noChangeAspect="1"/>
+          </p:cNvPicPr>
+          <p:nvPr/>
+        </p:nvPicPr>
+        <p:blipFill>
+          <a:blip r:embed="rId2"/>
+          <a:srcRect t="711" r="17265" b="1"/>
+          <a:stretch>
+            <a:fillRect/>
+          </a:stretch>
+        </p:blipFill>
+        <p:spPr>
+          <a:xfrm>
+            <a:off x="8862543" y="1674871"/>
+            <a:ext cx="3038305" cy="4183377"/>
+          </a:xfrm>
+          <a:prstGeom prst="rect">
+            <a:avLst/>
+          </a:prstGeom>
+        </p:spPr>
+      </p:pic>
+    </p:spTree>
+    <p:extLst>
+      <p:ext uri="{BB962C8B-B14F-4D97-AF65-F5344CB8AC3E}">
+        <p14:creationId xmlns:p14="http://schemas.microsoft.com/office/powerpoint/2010/main" val="2581270574"/>
+      </p:ext>
+    </p:extLst>
+  </p:cSld>
+  <p:clrMapOvr>
+    <a:masterClrMapping/>
+  </p:clrMapOvr>
+</p:sld>
+</file>
+
+<file path=ppt/slides/slide59.xml><?xml version="1.0" encoding="utf-8"?>
+<p:sld xmlns:a="http://schemas.openxmlformats.org/drawingml/2006/main" xmlns:r="http://schemas.openxmlformats.org/officeDocument/2006/relationships" xmlns:p="http://schemas.openxmlformats.org/presentationml/2006/main">
+  <p:cSld>
+    <p:spTree>
+      <p:nvGrpSpPr>
         <p:cNvPr id="1" name=""/>
         <p:cNvGrpSpPr/>
         <p:nvPr/>
@@ -31261,10 +31704,10 @@
       </p:grpSpPr>
       <p:sp>
         <p:nvSpPr>
-          <p:cNvPr id="2" name="Text Placeholder 1">
-            <a:extLst>
-              <a:ext uri="{FF2B5EF4-FFF2-40B4-BE49-F238E27FC236}">
-                <a16:creationId xmlns:a16="http://schemas.microsoft.com/office/drawing/2014/main" id="{77A024FE-483E-D3DD-DFD9-9EF2AE607D75}"/>
+          <p:cNvPr id="2" name="Title 1">
+            <a:extLst>
+              <a:ext uri="{FF2B5EF4-FFF2-40B4-BE49-F238E27FC236}">
+                <a16:creationId xmlns:a16="http://schemas.microsoft.com/office/drawing/2014/main" id="{F1A6FA56-D450-A3B1-92C4-FF6C2D6086D0}"/>
               </a:ext>
             </a:extLst>
           </p:cNvPr>
@@ -31272,7 +31715,7 @@
             <a:spLocks noGrp="1"/>
           </p:cNvSpPr>
           <p:nvPr>
-            <p:ph type="body" sz="quarter" idx="14"/>
+            <p:ph type="title"/>
           </p:nvPr>
         </p:nvSpPr>
         <p:spPr/>
@@ -31282,15 +31725,288 @@
           <a:p>
             <a:r>
               <a:rPr lang="en-US" dirty="0"/>
-              <a:t>THANK YOU</a:t>
+              <a:t>OLLAMA – BASIC COMMANDS</a:t>
             </a:r>
           </a:p>
         </p:txBody>
       </p:sp>
+      <p:sp>
+        <p:nvSpPr>
+          <p:cNvPr id="3" name="Content Placeholder 2">
+            <a:extLst>
+              <a:ext uri="{FF2B5EF4-FFF2-40B4-BE49-F238E27FC236}">
+                <a16:creationId xmlns:a16="http://schemas.microsoft.com/office/drawing/2014/main" id="{A357E9F6-5F59-7424-7DC4-FBD3C74CFA9E}"/>
+              </a:ext>
+            </a:extLst>
+          </p:cNvPr>
+          <p:cNvSpPr>
+            <a:spLocks noGrp="1"/>
+          </p:cNvSpPr>
+          <p:nvPr>
+            <p:ph idx="1"/>
+          </p:nvPr>
+        </p:nvSpPr>
+        <p:spPr>
+          <a:xfrm>
+            <a:off x="1081345" y="3138985"/>
+            <a:ext cx="10454184" cy="3431252"/>
+          </a:xfrm>
+        </p:spPr>
+        <p:txBody>
+          <a:bodyPr>
+            <a:normAutofit/>
+          </a:bodyPr>
+          <a:lstStyle/>
+          <a:p>
+            <a:pPr marL="0" indent="0">
+              <a:buNone/>
+            </a:pPr>
+            <a:r>
+              <a:rPr lang="en-US" dirty="0"/>
+              <a:t>The only time you need to touch a terminal is to install, list, or remove models. On Windows or MacOS, open your “Terminal” app. Then…</a:t>
+            </a:r>
+          </a:p>
+          <a:p>
+            <a:r>
+              <a:rPr lang="en-US" dirty="0">
+                <a:solidFill>
+                  <a:schemeClr val="accent1"/>
+                </a:solidFill>
+              </a:rPr>
+              <a:t>Show existing models</a:t>
+            </a:r>
+            <a:r>
+              <a:rPr lang="en-US" dirty="0"/>
+              <a:t>: </a:t>
+            </a:r>
+            <a:r>
+              <a:rPr lang="en-US" sz="2400" dirty="0" err="1">
+                <a:solidFill>
+                  <a:schemeClr val="accent4"/>
+                </a:solidFill>
+                <a:latin typeface="Consolas" panose="020B0609020204030204" pitchFamily="49" charset="0"/>
+              </a:rPr>
+              <a:t>ollama</a:t>
+            </a:r>
+            <a:r>
+              <a:rPr lang="en-US" sz="2400" dirty="0">
+                <a:solidFill>
+                  <a:schemeClr val="accent4"/>
+                </a:solidFill>
+                <a:latin typeface="Consolas" panose="020B0609020204030204" pitchFamily="49" charset="0"/>
+              </a:rPr>
+              <a:t> list</a:t>
+            </a:r>
+          </a:p>
+          <a:p>
+            <a:r>
+              <a:rPr lang="en-US" dirty="0">
+                <a:solidFill>
+                  <a:schemeClr val="accent1"/>
+                </a:solidFill>
+              </a:rPr>
+              <a:t>Install a model</a:t>
+            </a:r>
+            <a:r>
+              <a:rPr lang="en-US" dirty="0"/>
+              <a:t>: </a:t>
+            </a:r>
+            <a:r>
+              <a:rPr lang="en-US" sz="2400" dirty="0" err="1">
+                <a:solidFill>
+                  <a:schemeClr val="accent4"/>
+                </a:solidFill>
+                <a:latin typeface="Consolas" panose="020B0609020204030204" pitchFamily="49" charset="0"/>
+              </a:rPr>
+              <a:t>ollama</a:t>
+            </a:r>
+            <a:r>
+              <a:rPr lang="en-US" sz="2400" dirty="0">
+                <a:solidFill>
+                  <a:schemeClr val="accent4"/>
+                </a:solidFill>
+                <a:latin typeface="Consolas" panose="020B0609020204030204" pitchFamily="49" charset="0"/>
+              </a:rPr>
+              <a:t> install </a:t>
+            </a:r>
+            <a:r>
+              <a:rPr lang="en-US" sz="2400" i="1" dirty="0">
+                <a:solidFill>
+                  <a:schemeClr val="accent4">
+                    <a:lumMod val="20000"/>
+                    <a:lumOff val="80000"/>
+                  </a:schemeClr>
+                </a:solidFill>
+                <a:latin typeface="Consolas" panose="020B0609020204030204" pitchFamily="49" charset="0"/>
+              </a:rPr>
+              <a:t>&lt;</a:t>
+            </a:r>
+            <a:r>
+              <a:rPr lang="en-US" sz="2400" i="1" dirty="0" err="1">
+                <a:solidFill>
+                  <a:schemeClr val="accent4">
+                    <a:lumMod val="20000"/>
+                    <a:lumOff val="80000"/>
+                  </a:schemeClr>
+                </a:solidFill>
+                <a:latin typeface="Consolas" panose="020B0609020204030204" pitchFamily="49" charset="0"/>
+              </a:rPr>
+              <a:t>model_name</a:t>
+            </a:r>
+            <a:r>
+              <a:rPr lang="en-US" sz="2400" i="1" dirty="0">
+                <a:solidFill>
+                  <a:schemeClr val="accent4">
+                    <a:lumMod val="20000"/>
+                    <a:lumOff val="80000"/>
+                  </a:schemeClr>
+                </a:solidFill>
+                <a:latin typeface="Consolas" panose="020B0609020204030204" pitchFamily="49" charset="0"/>
+              </a:rPr>
+              <a:t>&gt;</a:t>
+            </a:r>
+          </a:p>
+          <a:p>
+            <a:pPr lvl="1"/>
+            <a:r>
+              <a:rPr lang="en-US" sz="2000" dirty="0"/>
+              <a:t>e.g., </a:t>
+            </a:r>
+            <a:r>
+              <a:rPr lang="en-US" sz="2000" dirty="0" err="1">
+                <a:solidFill>
+                  <a:schemeClr val="accent4">
+                    <a:lumMod val="20000"/>
+                    <a:lumOff val="80000"/>
+                  </a:schemeClr>
+                </a:solidFill>
+                <a:latin typeface="Consolas" panose="020B0609020204030204" pitchFamily="49" charset="0"/>
+              </a:rPr>
+              <a:t>ollama</a:t>
+            </a:r>
+            <a:r>
+              <a:rPr lang="en-US" sz="2000" dirty="0">
+                <a:solidFill>
+                  <a:schemeClr val="accent4">
+                    <a:lumMod val="20000"/>
+                    <a:lumOff val="80000"/>
+                  </a:schemeClr>
+                </a:solidFill>
+                <a:latin typeface="Consolas" panose="020B0609020204030204" pitchFamily="49" charset="0"/>
+              </a:rPr>
+              <a:t> install gemma4:e4b</a:t>
+            </a:r>
+          </a:p>
+          <a:p>
+            <a:r>
+              <a:rPr lang="en-US" dirty="0">
+                <a:solidFill>
+                  <a:schemeClr val="accent1"/>
+                </a:solidFill>
+              </a:rPr>
+              <a:t>Remove a model</a:t>
+            </a:r>
+            <a:r>
+              <a:rPr lang="en-US" dirty="0"/>
+              <a:t>: </a:t>
+            </a:r>
+            <a:r>
+              <a:rPr lang="en-US" sz="2400" dirty="0" err="1">
+                <a:solidFill>
+                  <a:schemeClr val="accent4"/>
+                </a:solidFill>
+                <a:latin typeface="Consolas" panose="020B0609020204030204" pitchFamily="49" charset="0"/>
+              </a:rPr>
+              <a:t>ollama</a:t>
+            </a:r>
+            <a:r>
+              <a:rPr lang="en-US" sz="2400" dirty="0">
+                <a:solidFill>
+                  <a:schemeClr val="accent4"/>
+                </a:solidFill>
+                <a:latin typeface="Consolas" panose="020B0609020204030204" pitchFamily="49" charset="0"/>
+              </a:rPr>
+              <a:t> rm </a:t>
+            </a:r>
+            <a:r>
+              <a:rPr lang="en-US" sz="2400" i="1" dirty="0">
+                <a:solidFill>
+                  <a:schemeClr val="accent4">
+                    <a:lumMod val="20000"/>
+                    <a:lumOff val="80000"/>
+                  </a:schemeClr>
+                </a:solidFill>
+                <a:latin typeface="Consolas" panose="020B0609020204030204" pitchFamily="49" charset="0"/>
+              </a:rPr>
+              <a:t>&lt;</a:t>
+            </a:r>
+            <a:r>
+              <a:rPr lang="en-US" sz="2400" i="1" dirty="0" err="1">
+                <a:solidFill>
+                  <a:schemeClr val="accent4">
+                    <a:lumMod val="20000"/>
+                    <a:lumOff val="80000"/>
+                  </a:schemeClr>
+                </a:solidFill>
+                <a:latin typeface="Consolas" panose="020B0609020204030204" pitchFamily="49" charset="0"/>
+              </a:rPr>
+              <a:t>model_name</a:t>
+            </a:r>
+            <a:r>
+              <a:rPr lang="en-US" sz="2400" i="1" dirty="0">
+                <a:solidFill>
+                  <a:schemeClr val="accent4">
+                    <a:lumMod val="20000"/>
+                    <a:lumOff val="80000"/>
+                  </a:schemeClr>
+                </a:solidFill>
+                <a:latin typeface="Consolas" panose="020B0609020204030204" pitchFamily="49" charset="0"/>
+              </a:rPr>
+              <a:t>&gt;</a:t>
+            </a:r>
+          </a:p>
+        </p:txBody>
+      </p:sp>
+      <p:pic>
+        <p:nvPicPr>
+          <p:cNvPr id="9" name="Picture 8" descr="Terminal with ollama list output">
+            <a:extLst>
+              <a:ext uri="{FF2B5EF4-FFF2-40B4-BE49-F238E27FC236}">
+                <a16:creationId xmlns:a16="http://schemas.microsoft.com/office/drawing/2014/main" id="{A7234235-050A-0E03-6A9F-2A2A21C5F81D}"/>
+              </a:ext>
+            </a:extLst>
+          </p:cNvPr>
+          <p:cNvPicPr>
+            <a:picLocks noChangeAspect="1"/>
+          </p:cNvPicPr>
+          <p:nvPr/>
+        </p:nvPicPr>
+        <p:blipFill>
+          <a:blip r:embed="rId2"/>
+          <a:srcRect b="9198"/>
+          <a:stretch>
+            <a:fillRect/>
+          </a:stretch>
+        </p:blipFill>
+        <p:spPr>
+          <a:xfrm>
+            <a:off x="1190527" y="1203494"/>
+            <a:ext cx="6173061" cy="1833818"/>
+          </a:xfrm>
+          <a:prstGeom prst="rect">
+            <a:avLst/>
+          </a:prstGeom>
+          <a:ln>
+            <a:solidFill>
+              <a:schemeClr val="bg1"/>
+            </a:solidFill>
+          </a:ln>
+        </p:spPr>
+      </p:pic>
     </p:spTree>
     <p:extLst>
       <p:ext uri="{BB962C8B-B14F-4D97-AF65-F5344CB8AC3E}">
-        <p14:creationId xmlns:p14="http://schemas.microsoft.com/office/powerpoint/2010/main" val="745710155"/>
+        <p14:creationId xmlns:p14="http://schemas.microsoft.com/office/powerpoint/2010/main" val="2088471297"/>
       </p:ext>
     </p:extLst>
   </p:cSld>
@@ -32057,6 +32773,64 @@
 </p:sld>
 </file>
 
+<file path=ppt/slides/slide60.xml><?xml version="1.0" encoding="utf-8"?>
+<p:sld xmlns:a="http://schemas.openxmlformats.org/drawingml/2006/main" xmlns:r="http://schemas.openxmlformats.org/officeDocument/2006/relationships" xmlns:p="http://schemas.openxmlformats.org/presentationml/2006/main">
+  <p:cSld>
+    <p:spTree>
+      <p:nvGrpSpPr>
+        <p:cNvPr id="1" name=""/>
+        <p:cNvGrpSpPr/>
+        <p:nvPr/>
+      </p:nvGrpSpPr>
+      <p:grpSpPr>
+        <a:xfrm>
+          <a:off x="0" y="0"/>
+          <a:ext cx="0" cy="0"/>
+          <a:chOff x="0" y="0"/>
+          <a:chExt cx="0" cy="0"/>
+        </a:xfrm>
+      </p:grpSpPr>
+      <p:sp>
+        <p:nvSpPr>
+          <p:cNvPr id="2" name="Text Placeholder 1">
+            <a:extLst>
+              <a:ext uri="{FF2B5EF4-FFF2-40B4-BE49-F238E27FC236}">
+                <a16:creationId xmlns:a16="http://schemas.microsoft.com/office/drawing/2014/main" id="{77A024FE-483E-D3DD-DFD9-9EF2AE607D75}"/>
+              </a:ext>
+            </a:extLst>
+          </p:cNvPr>
+          <p:cNvSpPr>
+            <a:spLocks noGrp="1"/>
+          </p:cNvSpPr>
+          <p:nvPr>
+            <p:ph type="body" sz="quarter" idx="14"/>
+          </p:nvPr>
+        </p:nvSpPr>
+        <p:spPr/>
+        <p:txBody>
+          <a:bodyPr/>
+          <a:lstStyle/>
+          <a:p>
+            <a:r>
+              <a:rPr lang="en-US" dirty="0"/>
+              <a:t>THANK YOU</a:t>
+            </a:r>
+          </a:p>
+        </p:txBody>
+      </p:sp>
+    </p:spTree>
+    <p:extLst>
+      <p:ext uri="{BB962C8B-B14F-4D97-AF65-F5344CB8AC3E}">
+        <p14:creationId xmlns:p14="http://schemas.microsoft.com/office/powerpoint/2010/main" val="745710155"/>
+      </p:ext>
+    </p:extLst>
+  </p:cSld>
+  <p:clrMapOvr>
+    <a:masterClrMapping/>
+  </p:clrMapOvr>
+</p:sld>
+</file>
+
 <file path=ppt/slides/slide7.xml><?xml version="1.0" encoding="utf-8"?>
 <p:sld xmlns:a="http://schemas.openxmlformats.org/drawingml/2006/main" xmlns:r="http://schemas.openxmlformats.org/officeDocument/2006/relationships" xmlns:p="http://schemas.openxmlformats.org/presentationml/2006/main">
   <p:cSld>
@@ -32473,7 +33247,7 @@
       </p:pic>
       <p:sp>
         <p:nvSpPr>
-          <p:cNvPr id="9" name="Rectangle: Rounded Corners 8">
+          <p:cNvPr id="9" name="Rectangle: Rounded Corners 8" descr="Open 3-Step Machine Learning Process link">
             <a:hlinkClick r:id="rId5"/>
             <a:extLst>
               <a:ext uri="{FF2B5EF4-FFF2-40B4-BE49-F238E27FC236}">

</xml_diff>

<commit_message>
Made titles unique so PDF reader is happy
</commit_message>
<xml_diff>
--- a/downloads/ai_ml_slides.pptx
+++ b/downloads/ai_ml_slides.pptx
@@ -8341,7 +8341,11 @@
                   <a:schemeClr val="accent2"/>
                 </a:solidFill>
               </a:rPr>
-              <a:t>IMPACTS OF ML BIAS</a:t>
+              <a:t>IMPACTS OF ML BIAS: </a:t>
+            </a:r>
+            <a:r>
+              <a:rPr lang="en-US" sz="2800" dirty="0"/>
+              <a:t>Coded Bias</a:t>
             </a:r>
           </a:p>
         </p:txBody>
@@ -8695,7 +8699,11 @@
                   <a:schemeClr val="accent2"/>
                 </a:solidFill>
               </a:rPr>
-              <a:t>IMPACTS OF ML BIAS</a:t>
+              <a:t>IMPACTS OF ML BIAS: </a:t>
+            </a:r>
+            <a:r>
+              <a:rPr lang="en-US" sz="2800" dirty="0"/>
+              <a:t>Dirty Data</a:t>
             </a:r>
           </a:p>
         </p:txBody>
@@ -9525,7 +9533,11 @@
           <a:p>
             <a:r>
               <a:rPr lang="en-US" sz="3300" dirty="0"/>
-              <a:t>WE USE ML TO TRAIN NEURAL NETWORKS</a:t>
+              <a:t>WE USE ML TO TRAIN NEURAL NETWORKS </a:t>
+            </a:r>
+            <a:r>
+              <a:rPr lang="en-US" sz="2000" dirty="0"/>
+              <a:t>1</a:t>
             </a:r>
           </a:p>
         </p:txBody>
@@ -10197,7 +10209,7 @@
       </p:sp>
       <p:pic>
         <p:nvPicPr>
-          <p:cNvPr id="35" name="Graphic 34" descr="Badge 1 with solid fill">
+          <p:cNvPr id="35" name="Graphic 34" descr="1">
             <a:extLst>
               <a:ext uri="{FF2B5EF4-FFF2-40B4-BE49-F238E27FC236}">
                 <a16:creationId xmlns:a16="http://schemas.microsoft.com/office/drawing/2014/main" id="{B75E3748-074F-AC8E-C5FD-B2E51910A2C2}"/>
@@ -10232,7 +10244,7 @@
       </p:pic>
       <p:pic>
         <p:nvPicPr>
-          <p:cNvPr id="36" name="Graphic 35" descr="Badge with solid fill">
+          <p:cNvPr id="36" name="Graphic 35" descr="2">
             <a:extLst>
               <a:ext uri="{FF2B5EF4-FFF2-40B4-BE49-F238E27FC236}">
                 <a16:creationId xmlns:a16="http://schemas.microsoft.com/office/drawing/2014/main" id="{05E2D38F-55CB-EBAF-AA03-1D1C2B7CCB6F}"/>
@@ -10267,7 +10279,7 @@
       </p:pic>
       <p:pic>
         <p:nvPicPr>
-          <p:cNvPr id="37" name="Graphic 36" descr="Badge 3 with solid fill">
+          <p:cNvPr id="37" name="Graphic 36" descr="3">
             <a:extLst>
               <a:ext uri="{FF2B5EF4-FFF2-40B4-BE49-F238E27FC236}">
                 <a16:creationId xmlns:a16="http://schemas.microsoft.com/office/drawing/2014/main" id="{5CFC77C8-3A2A-CC88-E04E-360625FA6D9D}"/>
@@ -10315,7 +10327,7 @@
         <p:spPr>
           <a:xfrm>
             <a:off x="2645158" y="4467195"/>
-            <a:ext cx="2238374" cy="400110"/>
+            <a:ext cx="1964942" cy="400110"/>
           </a:xfrm>
           <a:prstGeom prst="rect">
             <a:avLst/>
@@ -10354,7 +10366,7 @@
         <p:spPr>
           <a:xfrm>
             <a:off x="5153473" y="4467195"/>
-            <a:ext cx="2238374" cy="400110"/>
+            <a:ext cx="1490417" cy="400110"/>
           </a:xfrm>
           <a:prstGeom prst="rect">
             <a:avLst/>
@@ -11080,7 +11092,11 @@
           <a:p>
             <a:r>
               <a:rPr lang="en-US" sz="3300" dirty="0"/>
-              <a:t>WE USE ML TO TRAIN NEURAL NETWORKS</a:t>
+              <a:t>WE USE ML TO TRAIN NEURAL NETWORKS </a:t>
+            </a:r>
+            <a:r>
+              <a:rPr lang="en-US" sz="2000" dirty="0"/>
+              <a:t>2</a:t>
             </a:r>
           </a:p>
         </p:txBody>
@@ -13570,7 +13586,7 @@
       </p:sp>
       <p:pic>
         <p:nvPicPr>
-          <p:cNvPr id="8" name="Graphic 7" descr="Kitten with solid fill">
+          <p:cNvPr id="8" name="Graphic 7" descr="Kitten">
             <a:extLst>
               <a:ext uri="{FF2B5EF4-FFF2-40B4-BE49-F238E27FC236}">
                 <a16:creationId xmlns:a16="http://schemas.microsoft.com/office/drawing/2014/main" id="{41BF88DC-2A5E-5B43-9078-9DD131205175}"/>
@@ -13606,7 +13622,7 @@
       </p:pic>
       <p:pic>
         <p:nvPicPr>
-          <p:cNvPr id="9" name="Graphic 8" descr="Checkbox Checked with solid fill">
+          <p:cNvPr id="9" name="Graphic 8" descr="Checkbox Checked">
             <a:extLst>
               <a:ext uri="{FF2B5EF4-FFF2-40B4-BE49-F238E27FC236}">
                 <a16:creationId xmlns:a16="http://schemas.microsoft.com/office/drawing/2014/main" id="{49D0DFAC-2014-17FC-93C0-988E2B04C3C3}"/>
@@ -15362,7 +15378,7 @@
       </p:sp>
       <p:pic>
         <p:nvPicPr>
-          <p:cNvPr id="9" name="Graphic 8" descr="Glasses with solid fill">
+          <p:cNvPr id="9" name="Graphic 8" descr="Glasses">
             <a:extLst>
               <a:ext uri="{FF2B5EF4-FFF2-40B4-BE49-F238E27FC236}">
                 <a16:creationId xmlns:a16="http://schemas.microsoft.com/office/drawing/2014/main" id="{115A4A7E-072E-875A-B2B6-B9421DF52380}"/>
@@ -15635,7 +15651,7 @@
       </p:sp>
       <p:pic>
         <p:nvPicPr>
-          <p:cNvPr id="5" name="Graphic 4" descr="Glasses with solid fill">
+          <p:cNvPr id="5" name="Graphic 4" descr="Glasses">
             <a:extLst>
               <a:ext uri="{FF2B5EF4-FFF2-40B4-BE49-F238E27FC236}">
                 <a16:creationId xmlns:a16="http://schemas.microsoft.com/office/drawing/2014/main" id="{C48A1CB9-966E-01E5-CE12-73403E771CF3}"/>
@@ -17117,7 +17133,12 @@
             <p:ph type="title"/>
           </p:nvPr>
         </p:nvSpPr>
-        <p:spPr/>
+        <p:spPr>
+          <a:xfrm>
+            <a:off x="1542472" y="136525"/>
+            <a:ext cx="9697027" cy="685511"/>
+          </a:xfrm>
+        </p:spPr>
         <p:txBody>
           <a:bodyPr>
             <a:normAutofit fontScale="90000"/>
@@ -17126,7 +17147,7 @@
           <a:p>
             <a:r>
               <a:rPr lang="en-US" dirty="0"/>
-              <a:t>TOKENIZATION: </a:t>
+              <a:t>2. TOKENIZATION: </a:t>
             </a:r>
             <a:r>
               <a:rPr lang="en-US" sz="2700" dirty="0"/>
@@ -17806,7 +17827,7 @@
           <a:p>
             <a:r>
               <a:rPr lang="en-US" dirty="0"/>
-              <a:t>THE TRANSFORMER ARCHITECTURE</a:t>
+              <a:t>3. THE TRANSFORMER ARCHITECTURE</a:t>
             </a:r>
           </a:p>
         </p:txBody>
@@ -19044,7 +19065,7 @@
         <p:spPr>
           <a:xfrm>
             <a:off x="1542473" y="136525"/>
-            <a:ext cx="10373302" cy="685511"/>
+            <a:ext cx="6191827" cy="815975"/>
           </a:xfrm>
         </p:spPr>
         <p:txBody>
@@ -19054,8 +19075,12 @@
           <a:lstStyle/>
           <a:p>
             <a:r>
-              <a:rPr lang="en-US" sz="3000" dirty="0"/>
-              <a:t>MULTI-HEAD ATT’N = CONTEXTUAL UNDERSTANDING</a:t>
+              <a:rPr lang="en-US" sz="3700" dirty="0"/>
+              <a:t>MULTI-HEAD ATTENTION </a:t>
+            </a:r>
+            <a:r>
+              <a:rPr lang="en-US" sz="2000" dirty="0"/>
+              <a:t>FOR CONTEXTUAL UNDERSTANDING</a:t>
             </a:r>
           </a:p>
         </p:txBody>
@@ -20580,7 +20605,7 @@
           <a:p>
             <a:r>
               <a:rPr lang="en-US" dirty="0"/>
-              <a:t>The Context Changes Everything</a:t>
+              <a:t>THE CONTEXT CHANGES EVERYTHING</a:t>
             </a:r>
           </a:p>
         </p:txBody>
@@ -23092,7 +23117,15 @@
                   <a:schemeClr val="accent2"/>
                 </a:solidFill>
               </a:rPr>
-              <a:t>INFORMATION LITERACY IN THE AI ERA</a:t>
+              <a:t>INFORMATION LITERACY IN THE AI ERA </a:t>
+            </a:r>
+            <a:r>
+              <a:rPr lang="en-US" sz="2200" dirty="0">
+                <a:solidFill>
+                  <a:schemeClr val="accent2"/>
+                </a:solidFill>
+              </a:rPr>
+              <a:t>1</a:t>
             </a:r>
           </a:p>
         </p:txBody>
@@ -23738,7 +23771,15 @@
                   <a:schemeClr val="accent2"/>
                 </a:solidFill>
               </a:rPr>
-              <a:t>INFORMATION LITERACY IN THE AI ERA</a:t>
+              <a:t>INFORMATION LITERACY IN THE AI ERA </a:t>
+            </a:r>
+            <a:r>
+              <a:rPr lang="en-US" sz="2200" dirty="0">
+                <a:solidFill>
+                  <a:schemeClr val="accent2"/>
+                </a:solidFill>
+              </a:rPr>
+              <a:t>2</a:t>
             </a:r>
           </a:p>
         </p:txBody>

</xml_diff>

<commit_message>
Corrections to Ollama slides
</commit_message>
<xml_diff>
--- a/downloads/ai_ml_slides.pptx
+++ b/downloads/ai_ml_slides.pptx
@@ -367,7 +367,7 @@
           <a:p>
             <a:fld id="{FC353D21-AFFF-4353-815A-DF65D9157940}" type="datetimeFigureOut">
               <a:rPr lang="en-US" smtClean="0"/>
-              <a:t>4/15/2026</a:t>
+              <a:t>5/1/2026</a:t>
             </a:fld>
             <a:endParaRPr lang="en-US"/>
           </a:p>
@@ -1424,7 +1424,7 @@
             <a:fld id="{BF3F64B4-C509-489E-B9E0-3C1C30B4AF8A}" type="datetimeFigureOut">
               <a:rPr lang="en-US" smtClean="0"/>
               <a:pPr/>
-              <a:t>4/15/2026</a:t>
+              <a:t>5/1/2026</a:t>
             </a:fld>
             <a:endParaRPr lang="en-US" dirty="0"/>
           </a:p>
@@ -1667,7 +1667,7 @@
             <a:fld id="{BF3F64B4-C509-489E-B9E0-3C1C30B4AF8A}" type="datetimeFigureOut">
               <a:rPr lang="en-US" smtClean="0"/>
               <a:pPr/>
-              <a:t>4/15/2026</a:t>
+              <a:t>5/1/2026</a:t>
             </a:fld>
             <a:endParaRPr lang="en-US"/>
           </a:p>
@@ -2219,7 +2219,7 @@
             <a:fld id="{BF3F64B4-C509-489E-B9E0-3C1C30B4AF8A}" type="datetimeFigureOut">
               <a:rPr lang="en-US" smtClean="0"/>
               <a:pPr/>
-              <a:t>4/15/2026</a:t>
+              <a:t>5/1/2026</a:t>
             </a:fld>
             <a:endParaRPr lang="en-US"/>
           </a:p>
@@ -2514,7 +2514,7 @@
             <a:fld id="{BF3F64B4-C509-489E-B9E0-3C1C30B4AF8A}" type="datetimeFigureOut">
               <a:rPr lang="en-US" smtClean="0"/>
               <a:pPr/>
-              <a:t>4/15/2026</a:t>
+              <a:t>5/1/2026</a:t>
             </a:fld>
             <a:endParaRPr lang="en-US"/>
           </a:p>
@@ -3926,7 +3926,7 @@
           <a:p>
             <a:fld id="{BF3F64B4-C509-489E-B9E0-3C1C30B4AF8A}" type="datetimeFigureOut">
               <a:rPr lang="en-US" smtClean="0"/>
-              <a:t>4/15/2026</a:t>
+              <a:t>5/1/2026</a:t>
             </a:fld>
             <a:endParaRPr lang="en-US"/>
           </a:p>
@@ -4439,7 +4439,7 @@
             <a:fld id="{BF3F64B4-C509-489E-B9E0-3C1C30B4AF8A}" type="datetimeFigureOut">
               <a:rPr lang="en-US" smtClean="0"/>
               <a:pPr/>
-              <a:t>4/15/2026</a:t>
+              <a:t>5/1/2026</a:t>
             </a:fld>
             <a:endParaRPr lang="en-US" dirty="0"/>
           </a:p>
@@ -4890,7 +4890,7 @@
             <a:fld id="{BF3F64B4-C509-489E-B9E0-3C1C30B4AF8A}" type="datetimeFigureOut">
               <a:rPr lang="en-US" smtClean="0"/>
               <a:pPr/>
-              <a:t>4/15/2026</a:t>
+              <a:t>5/1/2026</a:t>
             </a:fld>
             <a:endParaRPr lang="en-US"/>
           </a:p>
@@ -5207,7 +5207,7 @@
             <a:fld id="{BF3F64B4-C509-489E-B9E0-3C1C30B4AF8A}" type="datetimeFigureOut">
               <a:rPr lang="en-US" smtClean="0"/>
               <a:pPr/>
-              <a:t>4/15/2026</a:t>
+              <a:t>5/1/2026</a:t>
             </a:fld>
             <a:endParaRPr lang="en-US"/>
           </a:p>
@@ -5524,7 +5524,7 @@
             <a:fld id="{BF3F64B4-C509-489E-B9E0-3C1C30B4AF8A}" type="datetimeFigureOut">
               <a:rPr lang="en-US" smtClean="0"/>
               <a:pPr/>
-              <a:t>4/15/2026</a:t>
+              <a:t>5/1/2026</a:t>
             </a:fld>
             <a:endParaRPr lang="en-US" dirty="0"/>
           </a:p>
@@ -5841,7 +5841,7 @@
             <a:fld id="{BF3F64B4-C509-489E-B9E0-3C1C30B4AF8A}" type="datetimeFigureOut">
               <a:rPr lang="en-US" smtClean="0"/>
               <a:pPr/>
-              <a:t>4/15/2026</a:t>
+              <a:t>5/1/2026</a:t>
             </a:fld>
             <a:endParaRPr lang="en-US"/>
           </a:p>
@@ -6157,7 +6157,7 @@
             <a:fld id="{BF3F64B4-C509-489E-B9E0-3C1C30B4AF8A}" type="datetimeFigureOut">
               <a:rPr lang="en-US" smtClean="0"/>
               <a:pPr/>
-              <a:t>4/15/2026</a:t>
+              <a:t>5/1/2026</a:t>
             </a:fld>
             <a:endParaRPr lang="en-US"/>
           </a:p>
@@ -6591,7 +6591,7 @@
             <a:fld id="{BF3F64B4-C509-489E-B9E0-3C1C30B4AF8A}" type="datetimeFigureOut">
               <a:rPr lang="en-US" smtClean="0"/>
               <a:pPr/>
-              <a:t>4/15/2026</a:t>
+              <a:t>5/1/2026</a:t>
             </a:fld>
             <a:endParaRPr lang="en-US"/>
           </a:p>
@@ -7143,7 +7143,7 @@
             <a:fld id="{BF3F64B4-C509-489E-B9E0-3C1C30B4AF8A}" type="datetimeFigureOut">
               <a:rPr lang="en-US" smtClean="0"/>
               <a:pPr/>
-              <a:t>4/15/2026</a:t>
+              <a:t>5/1/2026</a:t>
             </a:fld>
             <a:endParaRPr lang="en-US"/>
           </a:p>
@@ -7767,7 +7767,7 @@
           <a:p>
             <a:fld id="{BF3F64B4-C509-489E-B9E0-3C1C30B4AF8A}" type="datetimeFigureOut">
               <a:rPr lang="en-US" smtClean="0"/>
-              <a:t>4/15/2026</a:t>
+              <a:t>5/1/2026</a:t>
             </a:fld>
             <a:endParaRPr lang="en-US"/>
           </a:p>
@@ -20629,7 +20629,7 @@
         <p:spPr>
           <a:xfrm>
             <a:off x="838200" y="1390649"/>
-            <a:ext cx="10515600" cy="5124451"/>
+            <a:ext cx="10515600" cy="5181601"/>
           </a:xfrm>
         </p:spPr>
         <p:txBody>
@@ -31651,7 +31651,7 @@
               <a:rPr lang="en-US" i="1" dirty="0">
                 <a:sym typeface="Wingdings" panose="05000000000000000000" pitchFamily="2" charset="2"/>
               </a:rPr>
-              <a:t>“the 24-billion-parameter version of the gemma4 model”.</a:t>
+              <a:t>“the 26-billion-parameter version of the gemma4 model”.</a:t>
             </a:r>
           </a:p>
           <a:p>
@@ -31814,7 +31814,7 @@
                   <a:schemeClr val="accent1"/>
                 </a:solidFill>
               </a:rPr>
-              <a:t>Show existing models</a:t>
+              <a:t>Show installed models</a:t>
             </a:r>
             <a:r>
               <a:rPr lang="en-US" dirty="0"/>
@@ -31868,7 +31868,7 @@
                 </a:solidFill>
                 <a:latin typeface="Consolas" panose="020B0609020204030204" pitchFamily="49" charset="0"/>
               </a:rPr>
-              <a:t> install </a:t>
+              <a:t> pull </a:t>
             </a:r>
             <a:r>
               <a:rPr lang="en-US" sz="2400" i="1" dirty="0">
@@ -31935,8 +31935,78 @@
                 </a:solidFill>
                 <a:latin typeface="Consolas" panose="020B0609020204030204" pitchFamily="49" charset="0"/>
               </a:rPr>
-              <a:t> install gemma4:e4b</a:t>
-            </a:r>
+              <a:t> pull </a:t>
+            </a:r>
+            <a:r>
+              <a:rPr lang="en-US" sz="2000" dirty="0" err="1">
+                <a:solidFill>
+                  <a:schemeClr val="accent4">
+                    <a:lumMod val="20000"/>
+                    <a:lumOff val="80000"/>
+                  </a:schemeClr>
+                </a:solidFill>
+                <a:latin typeface="Consolas" panose="020B0609020204030204" pitchFamily="49" charset="0"/>
+              </a:rPr>
+              <a:t>haasrr</a:t>
+            </a:r>
+            <a:r>
+              <a:rPr lang="en-US" sz="2000" dirty="0">
+                <a:solidFill>
+                  <a:schemeClr val="accent4">
+                    <a:lumMod val="20000"/>
+                    <a:lumOff val="80000"/>
+                  </a:schemeClr>
+                </a:solidFill>
+                <a:latin typeface="Consolas" panose="020B0609020204030204" pitchFamily="49" charset="0"/>
+              </a:rPr>
+              <a:t>/</a:t>
+            </a:r>
+            <a:r>
+              <a:rPr lang="en-US" sz="2000" dirty="0" err="1">
+                <a:solidFill>
+                  <a:schemeClr val="accent4">
+                    <a:lumMod val="20000"/>
+                    <a:lumOff val="80000"/>
+                  </a:schemeClr>
+                </a:solidFill>
+                <a:latin typeface="Consolas" panose="020B0609020204030204" pitchFamily="49" charset="0"/>
+              </a:rPr>
+              <a:t>pickyrules</a:t>
+            </a:r>
+            <a:r>
+              <a:rPr lang="en-US" sz="2000" dirty="0">
+                <a:solidFill>
+                  <a:schemeClr val="accent4">
+                    <a:lumMod val="20000"/>
+                    <a:lumOff val="80000"/>
+                  </a:schemeClr>
+                </a:solidFill>
+                <a:latin typeface="Consolas" panose="020B0609020204030204" pitchFamily="49" charset="0"/>
+              </a:rPr>
+              <a:t>  </a:t>
+            </a:r>
+            <a:r>
+              <a:rPr lang="en-US" sz="2000" i="1" dirty="0">
+                <a:solidFill>
+                  <a:schemeClr val="accent1">
+                    <a:lumMod val="20000"/>
+                    <a:lumOff val="80000"/>
+                  </a:schemeClr>
+                </a:solidFill>
+                <a:latin typeface="Consolas" panose="020B0609020204030204" pitchFamily="49" charset="0"/>
+                <a:sym typeface="Wingdings" panose="05000000000000000000" pitchFamily="2" charset="2"/>
+              </a:rPr>
+              <a:t> My model for academic writing</a:t>
+            </a:r>
+            <a:endParaRPr lang="en-US" sz="2000" i="1" dirty="0">
+              <a:solidFill>
+                <a:schemeClr val="accent1">
+                  <a:lumMod val="20000"/>
+                  <a:lumOff val="80000"/>
+                </a:schemeClr>
+              </a:solidFill>
+              <a:latin typeface="Consolas" panose="020B0609020204030204" pitchFamily="49" charset="0"/>
+            </a:endParaRPr>
           </a:p>
           <a:p>
             <a:r>

</xml_diff>